<commit_message>
Revised contact information and updated photo reel for annual summit
</commit_message>
<xml_diff>
--- a/images/DM_Edited_Map.pptx
+++ b/images/DM_Edited_Map.pptx
@@ -118,7 +118,7 @@
 <file path=ppt/revisionInfo.xml><?xml version="1.0" encoding="utf-8"?>
 <p1510:revInfo xmlns:a="http://schemas.openxmlformats.org/drawingml/2006/main" xmlns:r="http://schemas.openxmlformats.org/officeDocument/2006/relationships" xmlns:p1510="http://schemas.microsoft.com/office/powerpoint/2015/10/main">
   <p1510:revLst>
-    <p1510:client id="{EB13411A-C333-4E6A-BAC3-A39ED7D5F86A}" v="1" dt="2026-03-09T16:38:44.306"/>
+    <p1510:client id="{7E6E6939-5395-4EF3-AE51-8A92E176AAE2}" v="5" dt="2026-05-07T19:42:00.548"/>
   </p1510:revLst>
 </p1510:revInfo>
 </file>
@@ -127,98 +127,153 @@
 <pc:chgInfo xmlns:a="http://schemas.openxmlformats.org/drawingml/2006/main" xmlns:r="http://schemas.openxmlformats.org/officeDocument/2006/relationships" xmlns:ac="http://schemas.microsoft.com/office/drawing/2013/main/command" xmlns:pc="http://schemas.microsoft.com/office/powerpoint/2013/main/command">
   <pc:docChgLst>
     <pc:chgData name="Young, Matthias" userId="a26bd408-92d4-49de-950a-28be7c6f128b" providerId="ADAL" clId="{8F95B4DC-2E9A-49F3-B27C-D1A9B08BD8D0}"/>
-    <pc:docChg chg="modSld">
-      <pc:chgData name="Young, Matthias" userId="a26bd408-92d4-49de-950a-28be7c6f128b" providerId="ADAL" clId="{8F95B4DC-2E9A-49F3-B27C-D1A9B08BD8D0}" dt="2026-03-09T16:38:44.306" v="0" actId="164"/>
+    <pc:docChg chg="undo redo custSel modSld modMainMaster">
+      <pc:chgData name="Young, Matthias" userId="a26bd408-92d4-49de-950a-28be7c6f128b" providerId="ADAL" clId="{8F95B4DC-2E9A-49F3-B27C-D1A9B08BD8D0}" dt="2026-05-07T19:42:00.548" v="26" actId="164"/>
       <pc:docMkLst>
         <pc:docMk/>
       </pc:docMkLst>
-      <pc:sldChg chg="addSp modSp">
-        <pc:chgData name="Young, Matthias" userId="a26bd408-92d4-49de-950a-28be7c6f128b" providerId="ADAL" clId="{8F95B4DC-2E9A-49F3-B27C-D1A9B08BD8D0}" dt="2026-03-09T16:38:44.306" v="0" actId="164"/>
+      <pc:sldChg chg="addSp delSp modSp mod">
+        <pc:chgData name="Young, Matthias" userId="a26bd408-92d4-49de-950a-28be7c6f128b" providerId="ADAL" clId="{8F95B4DC-2E9A-49F3-B27C-D1A9B08BD8D0}" dt="2026-05-07T19:42:00.548" v="26" actId="164"/>
         <pc:sldMkLst>
           <pc:docMk/>
           <pc:sldMk cId="1424829540" sldId="306"/>
         </pc:sldMkLst>
-        <pc:spChg chg="mod">
-          <ac:chgData name="Young, Matthias" userId="a26bd408-92d4-49de-950a-28be7c6f128b" providerId="ADAL" clId="{8F95B4DC-2E9A-49F3-B27C-D1A9B08BD8D0}" dt="2026-03-09T16:38:44.306" v="0" actId="164"/>
+        <pc:spChg chg="del">
+          <ac:chgData name="Young, Matthias" userId="a26bd408-92d4-49de-950a-28be7c6f128b" providerId="ADAL" clId="{8F95B4DC-2E9A-49F3-B27C-D1A9B08BD8D0}" dt="2026-05-07T19:26:10.227" v="9" actId="478"/>
+          <ac:spMkLst>
+            <pc:docMk/>
+            <pc:sldMk cId="1424829540" sldId="306"/>
+            <ac:spMk id="2" creationId="{0459E166-F62B-9009-114D-85F9E251932F}"/>
+          </ac:spMkLst>
+        </pc:spChg>
+        <pc:spChg chg="add mod ord topLvl">
+          <ac:chgData name="Young, Matthias" userId="a26bd408-92d4-49de-950a-28be7c6f128b" providerId="ADAL" clId="{8F95B4DC-2E9A-49F3-B27C-D1A9B08BD8D0}" dt="2026-05-07T19:42:00.548" v="26" actId="164"/>
+          <ac:spMkLst>
+            <pc:docMk/>
+            <pc:sldMk cId="1424829540" sldId="306"/>
+            <ac:spMk id="4" creationId="{952D9D45-A473-1B13-6A2C-C1FC4E979B84}"/>
+          </ac:spMkLst>
+        </pc:spChg>
+        <pc:spChg chg="mod ord topLvl">
+          <ac:chgData name="Young, Matthias" userId="a26bd408-92d4-49de-950a-28be7c6f128b" providerId="ADAL" clId="{8F95B4DC-2E9A-49F3-B27C-D1A9B08BD8D0}" dt="2026-05-07T19:42:00.548" v="26" actId="164"/>
           <ac:spMkLst>
             <pc:docMk/>
             <pc:sldMk cId="1424829540" sldId="306"/>
             <ac:spMk id="9" creationId="{CB212BF0-DBBF-80A6-C41D-F61ADD6632B0}"/>
           </ac:spMkLst>
         </pc:spChg>
-        <pc:spChg chg="mod">
-          <ac:chgData name="Young, Matthias" userId="a26bd408-92d4-49de-950a-28be7c6f128b" providerId="ADAL" clId="{8F95B4DC-2E9A-49F3-B27C-D1A9B08BD8D0}" dt="2026-03-09T16:38:44.306" v="0" actId="164"/>
+        <pc:spChg chg="mod ord topLvl">
+          <ac:chgData name="Young, Matthias" userId="a26bd408-92d4-49de-950a-28be7c6f128b" providerId="ADAL" clId="{8F95B4DC-2E9A-49F3-B27C-D1A9B08BD8D0}" dt="2026-05-07T19:42:00.548" v="26" actId="164"/>
           <ac:spMkLst>
             <pc:docMk/>
             <pc:sldMk cId="1424829540" sldId="306"/>
             <ac:spMk id="13" creationId="{4772258D-E009-B2C9-F5CC-36A9F0C23169}"/>
           </ac:spMkLst>
         </pc:spChg>
-        <pc:spChg chg="mod">
-          <ac:chgData name="Young, Matthias" userId="a26bd408-92d4-49de-950a-28be7c6f128b" providerId="ADAL" clId="{8F95B4DC-2E9A-49F3-B27C-D1A9B08BD8D0}" dt="2026-03-09T16:38:44.306" v="0" actId="164"/>
+        <pc:spChg chg="mod ord topLvl">
+          <ac:chgData name="Young, Matthias" userId="a26bd408-92d4-49de-950a-28be7c6f128b" providerId="ADAL" clId="{8F95B4DC-2E9A-49F3-B27C-D1A9B08BD8D0}" dt="2026-05-07T19:42:00.548" v="26" actId="164"/>
           <ac:spMkLst>
             <pc:docMk/>
             <pc:sldMk cId="1424829540" sldId="306"/>
             <ac:spMk id="18" creationId="{B8158E20-9F55-5D1A-3850-084061C1265A}"/>
           </ac:spMkLst>
         </pc:spChg>
-        <pc:spChg chg="mod">
-          <ac:chgData name="Young, Matthias" userId="a26bd408-92d4-49de-950a-28be7c6f128b" providerId="ADAL" clId="{8F95B4DC-2E9A-49F3-B27C-D1A9B08BD8D0}" dt="2026-03-09T16:38:44.306" v="0" actId="164"/>
+        <pc:spChg chg="mod ord topLvl">
+          <ac:chgData name="Young, Matthias" userId="a26bd408-92d4-49de-950a-28be7c6f128b" providerId="ADAL" clId="{8F95B4DC-2E9A-49F3-B27C-D1A9B08BD8D0}" dt="2026-05-07T19:42:00.548" v="26" actId="164"/>
           <ac:spMkLst>
             <pc:docMk/>
             <pc:sldMk cId="1424829540" sldId="306"/>
             <ac:spMk id="21" creationId="{ECB3A2FF-B5BD-F6E7-DFE2-2FC716C40BA0}"/>
           </ac:spMkLst>
         </pc:spChg>
-        <pc:spChg chg="mod">
-          <ac:chgData name="Young, Matthias" userId="a26bd408-92d4-49de-950a-28be7c6f128b" providerId="ADAL" clId="{8F95B4DC-2E9A-49F3-B27C-D1A9B08BD8D0}" dt="2026-03-09T16:38:44.306" v="0" actId="164"/>
+        <pc:spChg chg="mod ord topLvl">
+          <ac:chgData name="Young, Matthias" userId="a26bd408-92d4-49de-950a-28be7c6f128b" providerId="ADAL" clId="{8F95B4DC-2E9A-49F3-B27C-D1A9B08BD8D0}" dt="2026-05-07T19:42:00.548" v="26" actId="164"/>
           <ac:spMkLst>
             <pc:docMk/>
             <pc:sldMk cId="1424829540" sldId="306"/>
             <ac:spMk id="24" creationId="{D30E4BB9-996A-0E7E-CA16-917E819BE938}"/>
           </ac:spMkLst>
         </pc:spChg>
-        <pc:spChg chg="mod">
-          <ac:chgData name="Young, Matthias" userId="a26bd408-92d4-49de-950a-28be7c6f128b" providerId="ADAL" clId="{8F95B4DC-2E9A-49F3-B27C-D1A9B08BD8D0}" dt="2026-03-09T16:38:44.306" v="0" actId="164"/>
+        <pc:spChg chg="mod ord topLvl">
+          <ac:chgData name="Young, Matthias" userId="a26bd408-92d4-49de-950a-28be7c6f128b" providerId="ADAL" clId="{8F95B4DC-2E9A-49F3-B27C-D1A9B08BD8D0}" dt="2026-05-07T19:42:00.548" v="26" actId="164"/>
           <ac:spMkLst>
             <pc:docMk/>
             <pc:sldMk cId="1424829540" sldId="306"/>
             <ac:spMk id="27" creationId="{141B0FB1-4F42-2769-23F2-9172AB3E867B}"/>
           </ac:spMkLst>
         </pc:spChg>
-        <pc:spChg chg="mod">
-          <ac:chgData name="Young, Matthias" userId="a26bd408-92d4-49de-950a-28be7c6f128b" providerId="ADAL" clId="{8F95B4DC-2E9A-49F3-B27C-D1A9B08BD8D0}" dt="2026-03-09T16:38:44.306" v="0" actId="164"/>
+        <pc:spChg chg="mod ord topLvl">
+          <ac:chgData name="Young, Matthias" userId="a26bd408-92d4-49de-950a-28be7c6f128b" providerId="ADAL" clId="{8F95B4DC-2E9A-49F3-B27C-D1A9B08BD8D0}" dt="2026-05-07T19:42:00.548" v="26" actId="164"/>
           <ac:spMkLst>
             <pc:docMk/>
             <pc:sldMk cId="1424829540" sldId="306"/>
             <ac:spMk id="30" creationId="{0988546E-B990-87EA-28C5-F4B780FD7C0C}"/>
           </ac:spMkLst>
         </pc:spChg>
-        <pc:picChg chg="mod">
-          <ac:chgData name="Young, Matthias" userId="a26bd408-92d4-49de-950a-28be7c6f128b" providerId="ADAL" clId="{8F95B4DC-2E9A-49F3-B27C-D1A9B08BD8D0}" dt="2026-03-09T16:38:44.306" v="0" actId="164"/>
+        <pc:grpChg chg="mod">
+          <ac:chgData name="Young, Matthias" userId="a26bd408-92d4-49de-950a-28be7c6f128b" providerId="ADAL" clId="{8F95B4DC-2E9A-49F3-B27C-D1A9B08BD8D0}" dt="2026-05-07T19:26:14.817" v="10" actId="164"/>
+          <ac:grpSpMkLst>
+            <pc:docMk/>
+            <pc:sldMk cId="1424829540" sldId="306"/>
+            <ac:grpSpMk id="3" creationId="{5406966A-C468-4C32-2E27-AC0C00860C8B}"/>
+          </ac:grpSpMkLst>
+        </pc:grpChg>
+        <pc:grpChg chg="add mod">
+          <ac:chgData name="Young, Matthias" userId="a26bd408-92d4-49de-950a-28be7c6f128b" providerId="ADAL" clId="{8F95B4DC-2E9A-49F3-B27C-D1A9B08BD8D0}" dt="2026-05-07T19:41:02.436" v="15" actId="1076"/>
+          <ac:grpSpMkLst>
+            <pc:docMk/>
+            <pc:sldMk cId="1424829540" sldId="306"/>
+            <ac:grpSpMk id="5" creationId="{B864C293-3C08-4B11-5087-D3842FC8DAA4}"/>
+          </ac:grpSpMkLst>
+        </pc:grpChg>
+        <pc:picChg chg="mod ord topLvl">
+          <ac:chgData name="Young, Matthias" userId="a26bd408-92d4-49de-950a-28be7c6f128b" providerId="ADAL" clId="{8F95B4DC-2E9A-49F3-B27C-D1A9B08BD8D0}" dt="2026-05-07T19:42:00.548" v="26" actId="164"/>
           <ac:picMkLst>
             <pc:docMk/>
             <pc:sldMk cId="1424829540" sldId="306"/>
             <ac:picMk id="8" creationId="{12D4625E-B8AD-86C9-B88F-F0F506C009F4}"/>
           </ac:picMkLst>
         </pc:picChg>
-        <pc:picChg chg="mod">
-          <ac:chgData name="Young, Matthias" userId="a26bd408-92d4-49de-950a-28be7c6f128b" providerId="ADAL" clId="{8F95B4DC-2E9A-49F3-B27C-D1A9B08BD8D0}" dt="2026-03-09T16:38:44.306" v="0" actId="164"/>
+        <pc:picChg chg="add mod">
+          <ac:chgData name="Young, Matthias" userId="a26bd408-92d4-49de-950a-28be7c6f128b" providerId="ADAL" clId="{8F95B4DC-2E9A-49F3-B27C-D1A9B08BD8D0}" dt="2026-05-07T19:41:53.941" v="25"/>
+          <ac:picMkLst>
+            <pc:docMk/>
+            <pc:sldMk cId="1424829540" sldId="306"/>
+            <ac:picMk id="10" creationId="{E3764F94-7D2C-D943-A845-C3CCF3762B2F}"/>
+          </ac:picMkLst>
+        </pc:picChg>
+        <pc:picChg chg="mod ord topLvl">
+          <ac:chgData name="Young, Matthias" userId="a26bd408-92d4-49de-950a-28be7c6f128b" providerId="ADAL" clId="{8F95B4DC-2E9A-49F3-B27C-D1A9B08BD8D0}" dt="2026-05-07T19:42:00.548" v="26" actId="164"/>
+          <ac:picMkLst>
+            <pc:docMk/>
+            <pc:sldMk cId="1424829540" sldId="306"/>
+            <ac:picMk id="20" creationId="{9EE3A6BF-1E9F-1B57-CD0D-DF907C9E66D9}"/>
+          </ac:picMkLst>
+        </pc:picChg>
+        <pc:picChg chg="mod ord topLvl">
+          <ac:chgData name="Young, Matthias" userId="a26bd408-92d4-49de-950a-28be7c6f128b" providerId="ADAL" clId="{8F95B4DC-2E9A-49F3-B27C-D1A9B08BD8D0}" dt="2026-05-07T19:41:19.416" v="20" actId="167"/>
           <ac:picMkLst>
             <pc:docMk/>
             <pc:sldMk cId="1424829540" sldId="306"/>
             <ac:picMk id="23" creationId="{47C563B2-57DD-431D-72EF-A311A7C551C2}"/>
           </ac:picMkLst>
         </pc:picChg>
-        <pc:picChg chg="mod">
-          <ac:chgData name="Young, Matthias" userId="a26bd408-92d4-49de-950a-28be7c6f128b" providerId="ADAL" clId="{8F95B4DC-2E9A-49F3-B27C-D1A9B08BD8D0}" dt="2026-03-09T16:38:44.306" v="0" actId="164"/>
+      </pc:sldChg>
+      <pc:sldMasterChg chg="delSp mod">
+        <pc:chgData name="Young, Matthias" userId="a26bd408-92d4-49de-950a-28be7c6f128b" providerId="ADAL" clId="{8F95B4DC-2E9A-49F3-B27C-D1A9B08BD8D0}" dt="2026-05-07T19:41:43.074" v="24" actId="21"/>
+        <pc:sldMasterMkLst>
+          <pc:docMk/>
+          <pc:sldMasterMk cId="487438606" sldId="2147483648"/>
+        </pc:sldMasterMkLst>
+        <pc:picChg chg="del">
+          <ac:chgData name="Young, Matthias" userId="a26bd408-92d4-49de-950a-28be7c6f128b" providerId="ADAL" clId="{8F95B4DC-2E9A-49F3-B27C-D1A9B08BD8D0}" dt="2026-05-07T19:41:43.074" v="24" actId="21"/>
           <ac:picMkLst>
             <pc:docMk/>
-            <pc:sldMk cId="1424829540" sldId="306"/>
-            <ac:picMk id="26" creationId="{FAD783BE-D1F7-9E14-F25B-51C01F5A05AA}"/>
+            <pc:sldMasterMk cId="487438606" sldId="2147483648"/>
+            <ac:picMk id="10" creationId="{E3764F94-7D2C-D943-A845-C3CCF3762B2F}"/>
           </ac:picMkLst>
         </pc:picChg>
-      </pc:sldChg>
+      </pc:sldMasterChg>
     </pc:docChg>
   </pc:docChgLst>
 </pc:chgInfo>
@@ -306,7 +361,7 @@
           <a:p>
             <a:fld id="{BFEBF3DD-24B8-9D40-ABEB-B4A0E772B6FC}" type="datetimeFigureOut">
               <a:rPr lang="en-US" smtClean="0"/>
-              <a:t>3/9/2026</a:t>
+              <a:t>5/7/2026</a:t>
             </a:fld>
             <a:endParaRPr lang="en-US" dirty="0"/>
           </a:p>
@@ -958,10 +1013,10 @@
           <p:nvPr userDrawn="1"/>
         </p:nvPicPr>
         <p:blipFill>
-          <a:blip r:embed="rId3">
+          <a:blip>
             <a:extLst>
               <a:ext uri="{96DAC541-7B7A-43D3-8B79-37D633B846F1}">
-                <asvg:svgBlip xmlns:asvg="http://schemas.microsoft.com/office/drawing/2016/SVG/main" r:embed="rId4"/>
+                <asvg:svgBlip xmlns:asvg="http://schemas.microsoft.com/office/drawing/2016/SVG/main" r:embed="rId3"/>
               </a:ext>
             </a:extLst>
           </a:blip>
@@ -36239,10 +36294,10 @@
           <p:nvPr userDrawn="1"/>
         </p:nvPicPr>
         <p:blipFill>
-          <a:blip r:embed="rId4">
+          <a:blip>
             <a:extLst>
               <a:ext uri="{96DAC541-7B7A-43D3-8B79-37D633B846F1}">
-                <asvg:svgBlip xmlns:asvg="http://schemas.microsoft.com/office/drawing/2016/SVG/main" r:embed="rId5"/>
+                <asvg:svgBlip xmlns:asvg="http://schemas.microsoft.com/office/drawing/2016/SVG/main" r:embed="rId4"/>
               </a:ext>
             </a:extLst>
           </a:blip>
@@ -36275,10 +36330,10 @@
           <p:nvPr userDrawn="1"/>
         </p:nvPicPr>
         <p:blipFill>
-          <a:blip r:embed="rId6">
+          <a:blip>
             <a:extLst>
               <a:ext uri="{96DAC541-7B7A-43D3-8B79-37D633B846F1}">
-                <asvg:svgBlip xmlns:asvg="http://schemas.microsoft.com/office/drawing/2016/SVG/main" r:embed="rId7"/>
+                <asvg:svgBlip xmlns:asvg="http://schemas.microsoft.com/office/drawing/2016/SVG/main" r:embed="rId5"/>
               </a:ext>
             </a:extLst>
           </a:blip>
@@ -36714,10 +36769,10 @@
           <p:nvPr userDrawn="1"/>
         </p:nvPicPr>
         <p:blipFill>
-          <a:blip r:embed="rId4">
+          <a:blip>
             <a:extLst>
               <a:ext uri="{96DAC541-7B7A-43D3-8B79-37D633B846F1}">
-                <asvg:svgBlip xmlns:asvg="http://schemas.microsoft.com/office/drawing/2016/SVG/main" r:embed="rId5"/>
+                <asvg:svgBlip xmlns:asvg="http://schemas.microsoft.com/office/drawing/2016/SVG/main" r:embed="rId4"/>
               </a:ext>
             </a:extLst>
           </a:blip>
@@ -36750,10 +36805,10 @@
           <p:nvPr userDrawn="1"/>
         </p:nvPicPr>
         <p:blipFill>
-          <a:blip r:embed="rId6">
+          <a:blip>
             <a:extLst>
               <a:ext uri="{96DAC541-7B7A-43D3-8B79-37D633B846F1}">
-                <asvg:svgBlip xmlns:asvg="http://schemas.microsoft.com/office/drawing/2016/SVG/main" r:embed="rId7"/>
+                <asvg:svgBlip xmlns:asvg="http://schemas.microsoft.com/office/drawing/2016/SVG/main" r:embed="rId5"/>
               </a:ext>
             </a:extLst>
           </a:blip>
@@ -37099,10 +37154,10 @@
           <p:nvPr userDrawn="1"/>
         </p:nvPicPr>
         <p:blipFill>
-          <a:blip r:embed="rId4">
+          <a:blip>
             <a:extLst>
               <a:ext uri="{96DAC541-7B7A-43D3-8B79-37D633B846F1}">
-                <asvg:svgBlip xmlns:asvg="http://schemas.microsoft.com/office/drawing/2016/SVG/main" r:embed="rId5"/>
+                <asvg:svgBlip xmlns:asvg="http://schemas.microsoft.com/office/drawing/2016/SVG/main" r:embed="rId4"/>
               </a:ext>
             </a:extLst>
           </a:blip>
@@ -37135,10 +37190,10 @@
           <p:nvPr userDrawn="1"/>
         </p:nvPicPr>
         <p:blipFill>
-          <a:blip r:embed="rId6">
+          <a:blip>
             <a:extLst>
               <a:ext uri="{96DAC541-7B7A-43D3-8B79-37D633B846F1}">
-                <asvg:svgBlip xmlns:asvg="http://schemas.microsoft.com/office/drawing/2016/SVG/main" r:embed="rId7"/>
+                <asvg:svgBlip xmlns:asvg="http://schemas.microsoft.com/office/drawing/2016/SVG/main" r:embed="rId5"/>
               </a:ext>
             </a:extLst>
           </a:blip>
@@ -37682,10 +37737,10 @@
           <p:nvPr userDrawn="1"/>
         </p:nvPicPr>
         <p:blipFill>
-          <a:blip r:embed="rId3">
+          <a:blip>
             <a:extLst>
               <a:ext uri="{96DAC541-7B7A-43D3-8B79-37D633B846F1}">
-                <asvg:svgBlip xmlns:asvg="http://schemas.microsoft.com/office/drawing/2016/SVG/main" r:embed="rId4"/>
+                <asvg:svgBlip xmlns:asvg="http://schemas.microsoft.com/office/drawing/2016/SVG/main" r:embed="rId3"/>
               </a:ext>
             </a:extLst>
           </a:blip>
@@ -38231,10 +38286,10 @@
           <p:nvPr userDrawn="1"/>
         </p:nvPicPr>
         <p:blipFill>
-          <a:blip r:embed="rId3">
+          <a:blip>
             <a:extLst>
               <a:ext uri="{96DAC541-7B7A-43D3-8B79-37D633B846F1}">
-                <asvg:svgBlip xmlns:asvg="http://schemas.microsoft.com/office/drawing/2016/SVG/main" r:embed="rId4"/>
+                <asvg:svgBlip xmlns:asvg="http://schemas.microsoft.com/office/drawing/2016/SVG/main" r:embed="rId3"/>
               </a:ext>
             </a:extLst>
           </a:blip>
@@ -39969,42 +40024,6 @@
           <a:ln>
             <a:noFill/>
           </a:ln>
-        </p:spPr>
-      </p:pic>
-      <p:pic>
-        <p:nvPicPr>
-          <p:cNvPr id="10" name="Graphic 9">
-            <a:extLst>
-              <a:ext uri="{FF2B5EF4-FFF2-40B4-BE49-F238E27FC236}">
-                <a16:creationId xmlns:a16="http://schemas.microsoft.com/office/drawing/2014/main" id="{E3764F94-7D2C-D943-A845-C3CCF3762B2F}"/>
-              </a:ext>
-            </a:extLst>
-          </p:cNvPr>
-          <p:cNvPicPr>
-            <a:picLocks noChangeAspect="1"/>
-          </p:cNvPicPr>
-          <p:nvPr userDrawn="1"/>
-        </p:nvPicPr>
-        <p:blipFill>
-          <a:blip r:embed="rId44">
-            <a:extLst>
-              <a:ext uri="{96DAC541-7B7A-43D3-8B79-37D633B846F1}">
-                <asvg:svgBlip xmlns:asvg="http://schemas.microsoft.com/office/drawing/2016/SVG/main" r:embed="rId45"/>
-              </a:ext>
-            </a:extLst>
-          </a:blip>
-          <a:stretch>
-            <a:fillRect/>
-          </a:stretch>
-        </p:blipFill>
-        <p:spPr>
-          <a:xfrm>
-            <a:off x="723900" y="6057900"/>
-            <a:ext cx="1756317" cy="342900"/>
-          </a:xfrm>
-          <a:prstGeom prst="rect">
-            <a:avLst/>
-          </a:prstGeom>
         </p:spPr>
       </p:pic>
     </p:spTree>
@@ -40562,42 +40581,12 @@
           <a:chExt cx="0" cy="0"/>
         </a:xfrm>
       </p:grpSpPr>
-      <p:sp>
-        <p:nvSpPr>
-          <p:cNvPr id="2" name="Slide Number Placeholder 1">
+      <p:grpSp>
+        <p:nvGrpSpPr>
+          <p:cNvPr id="2" name="Group 1">
             <a:extLst>
               <a:ext uri="{FF2B5EF4-FFF2-40B4-BE49-F238E27FC236}">
-                <a16:creationId xmlns:a16="http://schemas.microsoft.com/office/drawing/2014/main" id="{0459E166-F62B-9009-114D-85F9E251932F}"/>
-              </a:ext>
-            </a:extLst>
-          </p:cNvPr>
-          <p:cNvSpPr>
-            <a:spLocks noGrp="1"/>
-          </p:cNvSpPr>
-          <p:nvPr>
-            <p:ph type="sldNum" sz="quarter" idx="12"/>
-          </p:nvPr>
-        </p:nvSpPr>
-        <p:spPr/>
-        <p:txBody>
-          <a:bodyPr/>
-          <a:lstStyle/>
-          <a:p>
-            <a:fld id="{DCFE8AC6-424E-904F-AE4A-648F5E9D72F5}" type="slidenum">
-              <a:rPr lang="en-US" smtClean="0"/>
-              <a:pPr/>
-              <a:t>1</a:t>
-            </a:fld>
-            <a:endParaRPr lang="en-US" dirty="0"/>
-          </a:p>
-        </p:txBody>
-      </p:sp>
-      <p:grpSp>
-        <p:nvGrpSpPr>
-          <p:cNvPr id="3" name="Group 2">
-            <a:extLst>
-              <a:ext uri="{FF2B5EF4-FFF2-40B4-BE49-F238E27FC236}">
-                <a16:creationId xmlns:a16="http://schemas.microsoft.com/office/drawing/2014/main" id="{5406966A-C468-4C32-2E27-AC0C00860C8B}"/>
+                <a16:creationId xmlns:a16="http://schemas.microsoft.com/office/drawing/2014/main" id="{988F229F-A2EB-8162-650A-FB02E29A9874}"/>
               </a:ext>
             </a:extLst>
           </p:cNvPr>
@@ -40606,12 +40595,66 @@
         </p:nvGrpSpPr>
         <p:grpSpPr>
           <a:xfrm>
-            <a:off x="459180" y="539495"/>
-            <a:ext cx="11456557" cy="5954270"/>
-            <a:chOff x="459180" y="539495"/>
-            <a:chExt cx="11456557" cy="5954270"/>
+            <a:off x="286302" y="500332"/>
+            <a:ext cx="11721668" cy="6124755"/>
+            <a:chOff x="286302" y="500332"/>
+            <a:chExt cx="11721668" cy="6124755"/>
           </a:xfrm>
         </p:grpSpPr>
+        <p:sp>
+          <p:nvSpPr>
+            <p:cNvPr id="4" name="Rectangle 3">
+              <a:extLst>
+                <a:ext uri="{FF2B5EF4-FFF2-40B4-BE49-F238E27FC236}">
+                  <a16:creationId xmlns:a16="http://schemas.microsoft.com/office/drawing/2014/main" id="{952D9D45-A473-1B13-6A2C-C1FC4E979B84}"/>
+                </a:ext>
+              </a:extLst>
+            </p:cNvPr>
+            <p:cNvSpPr/>
+            <p:nvPr/>
+          </p:nvSpPr>
+          <p:spPr>
+            <a:xfrm>
+              <a:off x="286302" y="500332"/>
+              <a:ext cx="11721668" cy="6124755"/>
+            </a:xfrm>
+            <a:prstGeom prst="rect">
+              <a:avLst/>
+            </a:prstGeom>
+            <a:solidFill>
+              <a:schemeClr val="bg1"/>
+            </a:solidFill>
+            <a:ln>
+              <a:solidFill>
+                <a:schemeClr val="bg1"/>
+              </a:solidFill>
+            </a:ln>
+          </p:spPr>
+          <p:style>
+            <a:lnRef idx="2">
+              <a:schemeClr val="accent1">
+                <a:shade val="15000"/>
+              </a:schemeClr>
+            </a:lnRef>
+            <a:fillRef idx="1">
+              <a:schemeClr val="accent1"/>
+            </a:fillRef>
+            <a:effectRef idx="0">
+              <a:schemeClr val="accent1"/>
+            </a:effectRef>
+            <a:fontRef idx="minor">
+              <a:schemeClr val="lt1"/>
+            </a:fontRef>
+          </p:style>
+          <p:txBody>
+            <a:bodyPr rtlCol="0" anchor="ctr"/>
+            <a:lstStyle/>
+            <a:p>
+              <a:pPr algn="ctr"/>
+              <a:endParaRPr lang="en-US"/>
+            </a:p>
+          </p:txBody>
+        </p:sp>
         <p:pic>
           <p:nvPicPr>
             <p:cNvPr id="8" name="Picture 7">
@@ -41216,6 +41259,42 @@
             <a:xfrm>
               <a:off x="573324" y="5317332"/>
               <a:ext cx="2188164" cy="452251"/>
+            </a:xfrm>
+            <a:prstGeom prst="rect">
+              <a:avLst/>
+            </a:prstGeom>
+          </p:spPr>
+        </p:pic>
+        <p:pic>
+          <p:nvPicPr>
+            <p:cNvPr id="10" name="Graphic 9">
+              <a:extLst>
+                <a:ext uri="{FF2B5EF4-FFF2-40B4-BE49-F238E27FC236}">
+                  <a16:creationId xmlns:a16="http://schemas.microsoft.com/office/drawing/2014/main" id="{E3764F94-7D2C-D943-A845-C3CCF3762B2F}"/>
+                </a:ext>
+              </a:extLst>
+            </p:cNvPr>
+            <p:cNvPicPr>
+              <a:picLocks noChangeAspect="1"/>
+            </p:cNvPicPr>
+            <p:nvPr/>
+          </p:nvPicPr>
+          <p:blipFill>
+            <a:blip>
+              <a:extLst>
+                <a:ext uri="{96DAC541-7B7A-43D3-8B79-37D633B846F1}">
+                  <asvg:svgBlip xmlns:asvg="http://schemas.microsoft.com/office/drawing/2016/SVG/main" r:embed="rId9"/>
+                </a:ext>
+              </a:extLst>
+            </a:blip>
+            <a:stretch>
+              <a:fillRect/>
+            </a:stretch>
+          </p:blipFill>
+          <p:spPr>
+            <a:xfrm>
+              <a:off x="723900" y="6057900"/>
+              <a:ext cx="1756317" cy="342900"/>
             </a:xfrm>
             <a:prstGeom prst="rect">
               <a:avLst/>

</xml_diff>